<commit_message>
fix: minor slide optimization
</commit_message>
<xml_diff>
--- a/documentation/Session 1.pptx
+++ b/documentation/Session 1.pptx
@@ -10124,7 +10124,7 @@
                   <a:schemeClr val="bg1"/>
                 </a:solidFill>
               </a:rPr>
-              <a:t>Keep track of datasets you’ve seen</a:t>
+              <a:t>Keep track of datasets you’ve seen!</a:t>
             </a:r>
           </a:p>
           <a:p>
@@ -10865,7 +10865,7 @@
                   <a:srgbClr val="72AF2F"/>
                 </a:solidFill>
               </a:rPr>
-              <a:t>Folder structure, clean code conventions, tests</a:t>
+              <a:t>Folder structure, clean code conventions, test strategy</a:t>
             </a:r>
           </a:p>
           <a:p>
@@ -11754,7 +11754,7 @@
                   <a:srgbClr val="72AF2F"/>
                 </a:solidFill>
               </a:rPr>
-              <a:t>rich output</a:t>
+              <a:t>rich in-place output</a:t>
             </a:r>
           </a:p>
           <a:p>
@@ -18600,7 +18600,7 @@
                   <a:schemeClr val="bg1"/>
                 </a:solidFill>
               </a:rPr>
-              <a:t>data_processing.ipynb</a:t>
+              <a:t>data_preparation.ipynb</a:t>
             </a:r>
             <a:endParaRPr lang="en-US" sz="2000" dirty="0">
               <a:solidFill>
@@ -24476,7 +24476,7 @@
                 </a:solidFill>
                 <a:sym typeface="Wingdings" panose="05000000000000000000" pitchFamily="2" charset="2"/>
               </a:rPr>
-              <a:t>             The Answers are for you. No submission needed.</a:t>
+              <a:t>             The answers are for you. No submission needed.</a:t>
             </a:r>
             <a:endParaRPr lang="en-US" sz="2200" dirty="0">
               <a:solidFill>
@@ -24495,11 +24495,14 @@
             <a:pPr marL="1074738" indent="0">
               <a:buNone/>
             </a:pPr>
-            <a:endParaRPr lang="en-US" sz="2000" dirty="0">
-              <a:solidFill>
-                <a:srgbClr val="72AF2F"/>
-              </a:solidFill>
-            </a:endParaRPr>
+            <a:r>
+              <a:rPr lang="en-US" sz="2000" dirty="0">
+                <a:solidFill>
+                  <a:srgbClr val="72AF2F"/>
+                </a:solidFill>
+              </a:rPr>
+              <a:t>It is a good idea to also download and set up the example Machine Learning Project </a:t>
+            </a:r>
           </a:p>
         </p:txBody>
       </p:sp>
@@ -24607,6 +24610,55 @@
                                           <p:spTgt spid="4">
                                             <p:txEl>
                                               <p:pRg st="6" end="6"/>
+                                            </p:txEl>
+                                          </p:spTgt>
+                                        </p:tgtEl>
+                                        <p:attrNameLst>
+                                          <p:attrName>style.visibility</p:attrName>
+                                        </p:attrNameLst>
+                                      </p:cBhvr>
+                                      <p:to>
+                                        <p:strVal val="visible"/>
+                                      </p:to>
+                                    </p:set>
+                                  </p:childTnLst>
+                                </p:cTn>
+                              </p:par>
+                            </p:childTnLst>
+                          </p:cTn>
+                        </p:par>
+                      </p:childTnLst>
+                    </p:cTn>
+                  </p:par>
+                  <p:par>
+                    <p:cTn id="11" fill="hold">
+                      <p:stCondLst>
+                        <p:cond delay="indefinite"/>
+                      </p:stCondLst>
+                      <p:childTnLst>
+                        <p:par>
+                          <p:cTn id="12" fill="hold">
+                            <p:stCondLst>
+                              <p:cond delay="0"/>
+                            </p:stCondLst>
+                            <p:childTnLst>
+                              <p:par>
+                                <p:cTn id="13" presetID="1" presetClass="entr" presetSubtype="0" fill="hold" nodeType="clickEffect">
+                                  <p:stCondLst>
+                                    <p:cond delay="0"/>
+                                  </p:stCondLst>
+                                  <p:childTnLst>
+                                    <p:set>
+                                      <p:cBhvr>
+                                        <p:cTn id="14" dur="1" fill="hold">
+                                          <p:stCondLst>
+                                            <p:cond delay="0"/>
+                                          </p:stCondLst>
+                                        </p:cTn>
+                                        <p:tgtEl>
+                                          <p:spTgt spid="4">
+                                            <p:txEl>
+                                              <p:pRg st="8" end="8"/>
                                             </p:txEl>
                                           </p:spTgt>
                                         </p:tgtEl>
@@ -25688,29 +25740,6 @@
                 </a:solidFill>
               </a:rPr>
               <a:t>Specific libraries</a:t>
-            </a:r>
-          </a:p>
-          <a:p>
-            <a:pPr marL="114300" lvl="0" indent="0">
-              <a:buNone/>
-            </a:pPr>
-            <a:endParaRPr lang="en-US" sz="1000" dirty="0">
-              <a:solidFill>
-                <a:schemeClr val="tx1"/>
-              </a:solidFill>
-            </a:endParaRPr>
-          </a:p>
-          <a:p>
-            <a:pPr marL="114300" lvl="0" indent="0">
-              <a:buNone/>
-            </a:pPr>
-            <a:r>
-              <a:rPr lang="en-US" sz="2200" dirty="0">
-                <a:solidFill>
-                  <a:schemeClr val="tx1"/>
-                </a:solidFill>
-              </a:rPr>
-              <a:t>We will take attendance</a:t>
             </a:r>
           </a:p>
         </p:txBody>
@@ -26036,55 +26065,6 @@
                                           <p:spTgt spid="97">
                                             <p:txEl>
                                               <p:pRg st="8" end="8"/>
-                                            </p:txEl>
-                                          </p:spTgt>
-                                        </p:tgtEl>
-                                        <p:attrNameLst>
-                                          <p:attrName>style.visibility</p:attrName>
-                                        </p:attrNameLst>
-                                      </p:cBhvr>
-                                      <p:to>
-                                        <p:strVal val="visible"/>
-                                      </p:to>
-                                    </p:set>
-                                  </p:childTnLst>
-                                </p:cTn>
-                              </p:par>
-                            </p:childTnLst>
-                          </p:cTn>
-                        </p:par>
-                      </p:childTnLst>
-                    </p:cTn>
-                  </p:par>
-                  <p:par>
-                    <p:cTn id="23" fill="hold">
-                      <p:stCondLst>
-                        <p:cond delay="indefinite"/>
-                      </p:stCondLst>
-                      <p:childTnLst>
-                        <p:par>
-                          <p:cTn id="24" fill="hold">
-                            <p:stCondLst>
-                              <p:cond delay="0"/>
-                            </p:stCondLst>
-                            <p:childTnLst>
-                              <p:par>
-                                <p:cTn id="25" presetID="1" presetClass="entr" presetSubtype="0" fill="hold" nodeType="clickEffect">
-                                  <p:stCondLst>
-                                    <p:cond delay="0"/>
-                                  </p:stCondLst>
-                                  <p:childTnLst>
-                                    <p:set>
-                                      <p:cBhvr>
-                                        <p:cTn id="26" dur="1" fill="hold">
-                                          <p:stCondLst>
-                                            <p:cond delay="0"/>
-                                          </p:stCondLst>
-                                        </p:cTn>
-                                        <p:tgtEl>
-                                          <p:spTgt spid="97">
-                                            <p:txEl>
-                                              <p:pRg st="10" end="10"/>
                                             </p:txEl>
                                           </p:spTgt>
                                         </p:tgtEl>
@@ -31619,7 +31599,7 @@
           <p:nvPr>
             <p:extLst>
               <p:ext uri="{D42A27DB-BD31-4B8C-83A1-F6EECF244321}">
-                <p14:modId xmlns:p14="http://schemas.microsoft.com/office/powerpoint/2010/main" val="1222483134"/>
+                <p14:modId xmlns:p14="http://schemas.microsoft.com/office/powerpoint/2010/main" val="613232113"/>
               </p:ext>
             </p:extLst>
           </p:nvPr>
@@ -32859,7 +32839,7 @@
                             <a:schemeClr val="bg1"/>
                           </a:solidFill>
                         </a:rPr>
-                        <a:t>On per </a:t>
+                        <a:t>One per </a:t>
                       </a:r>
                       <a:r>
                         <a:rPr lang="en-US" dirty="0" err="1">

</xml_diff>